<commit_message>
Run the new S02 renders and refresh the deck
All ten models now cover the 121-instance set, and S02 discriminates instead
of being answerable by finding the SH2 domain:

  GPT-6 Astra, Opus 5, Kimi K3, MiniMax M3   1.000
  DeepSeek V4 Flash, Qwen3.5 9B              0.889
  gpt-oss-120b                               0.333
  gpt-oss-20b                                0.222

That is the point of the rebuild. One component and one domain family could
be answered by pattern-matching the fold; three components across five
families cannot, and the spread shows the family still separates models.

Headline scores barely move, which is expected -- four instances against 121
-- but they move honestly: DeepSeek 0.699 -> 0.718, gpt-oss-120b 0.259 ->
0.271, gpt-oss-20b 0.211 -> 0.221.

Gemma 4 31B's top-up was still running when this was scored, so its coverage
stays at 156 renders and is marked incomplete rather than averaged against
the rest.

Co-Authored-By: Claude Opus 5 <noreply@anthropic.com>
</commit_message>
<xml_diff>
--- a/docs/slides/pdbthink-results-2026-09-09.pptx
+++ b/docs/slides/pdbthink-results-2026-09-09.pptx
@@ -285,13 +285,13 @@
                 <c:formatCode>General</c:formatCode>
                 <c:ptCount val="9"/>
                 <c:pt idx="0">
-                  <c:v>0.21141178266178265</c:v>
+                  <c:v>0.2207371794871795</c:v>
                 </c:pt>
                 <c:pt idx="1">
-                  <c:v>0.2588306323306323</c:v>
+                  <c:v>0.27119174344174346</c:v>
                 </c:pt>
                 <c:pt idx="2">
-                  <c:v>0.3860119047619048</c:v>
+                  <c:v>0.37956349206349205</c:v>
                 </c:pt>
                 <c:pt idx="3">
                   <c:v>0.5124060846560846</c:v>
@@ -300,7 +300,7 @@
                   <c:v>0.6182738095238095</c:v>
                 </c:pt>
                 <c:pt idx="5">
-                  <c:v>0.6992048730746436</c:v>
+                  <c:v>0.7175467098093375</c:v>
                 </c:pt>
                 <c:pt idx="6">
                   <c:v>0.7617662892662893</c:v>
@@ -581,13 +581,13 @@
                 <c:formatCode>General</c:formatCode>
                 <c:ptCount val="9"/>
                 <c:pt idx="0">
-                  <c:v>0.30566137566137563</c:v>
+                  <c:v>0.3153615520282187</c:v>
                 </c:pt>
                 <c:pt idx="1">
-                  <c:v>0.27223972323972323</c:v>
+                  <c:v>0.2865254375254375</c:v>
                 </c:pt>
                 <c:pt idx="2">
-                  <c:v>0.6730769230769231</c:v>
+                  <c:v>0.6666666666666666</c:v>
                 </c:pt>
                 <c:pt idx="3">
                   <c:v>0.8682773109243698</c:v>
@@ -596,7 +596,7 @@
                   <c:v>0.7536375661375662</c:v>
                 </c:pt>
                 <c:pt idx="5">
-                  <c:v>0.854546453853933</c:v>
+                  <c:v>0.8668987631987236</c:v>
                 </c:pt>
                 <c:pt idx="6">
                   <c:v>0.9501984126984127</c:v>
@@ -5100,7 +5100,7 @@
                 </a:solidFill>
                 <a:latin typeface="Consolas"/>
               </a:rPr>
-              <a:t>1/247</a:t>
+              <a:t>1/253</a:t>
             </a:r>
           </a:p>
         </p:txBody>
@@ -5373,7 +5373,7 @@
                 </a:solidFill>
                 <a:latin typeface="Consolas"/>
               </a:rPr>
-              <a:t>15/247</a:t>
+              <a:t>15/253</a:t>
             </a:r>
           </a:p>
         </p:txBody>
@@ -5646,7 +5646,7 @@
                 </a:solidFill>
                 <a:latin typeface="Consolas"/>
               </a:rPr>
-              <a:t>4/247</a:t>
+              <a:t>4/253</a:t>
             </a:r>
           </a:p>
         </p:txBody>
@@ -5919,7 +5919,7 @@
                 </a:solidFill>
                 <a:latin typeface="Consolas"/>
               </a:rPr>
-              <a:t>75/247</a:t>
+              <a:t>75/253</a:t>
             </a:r>
           </a:p>
         </p:txBody>
@@ -6192,7 +6192,7 @@
                 </a:solidFill>
                 <a:latin typeface="Consolas"/>
               </a:rPr>
-              <a:t>133/246</a:t>
+              <a:t>134/253</a:t>
             </a:r>
           </a:p>
         </p:txBody>
@@ -6465,7 +6465,7 @@
                 </a:solidFill>
                 <a:latin typeface="Consolas"/>
               </a:rPr>
-              <a:t>6/229</a:t>
+              <a:t>9/253</a:t>
             </a:r>
           </a:p>
         </p:txBody>
@@ -6738,7 +6738,7 @@
                 </a:solidFill>
                 <a:latin typeface="Consolas"/>
               </a:rPr>
-              <a:t>71/242</a:t>
+              <a:t>74/253</a:t>
             </a:r>
           </a:p>
         </p:txBody>
@@ -7309,7 +7309,7 @@
                 </a:solidFill>
                 <a:latin typeface="Consolas"/>
               </a:rPr>
-              <a:t>247</a:t>
+              <a:t>253</a:t>
             </a:r>
           </a:p>
         </p:txBody>
@@ -7465,7 +7465,7 @@
                 </a:solidFill>
                 <a:latin typeface="Consolas"/>
               </a:rPr>
-              <a:t>0/247</a:t>
+              <a:t>0/253</a:t>
             </a:r>
           </a:p>
         </p:txBody>
@@ -7591,7 +7591,7 @@
                 </a:solidFill>
                 <a:latin typeface="Consolas"/>
               </a:rPr>
-              <a:t>247</a:t>
+              <a:t>253</a:t>
             </a:r>
           </a:p>
         </p:txBody>
@@ -7747,7 +7747,7 @@
                 </a:solidFill>
                 <a:latin typeface="Consolas"/>
               </a:rPr>
-              <a:t>13/247</a:t>
+              <a:t>13/253</a:t>
             </a:r>
           </a:p>
         </p:txBody>
@@ -7873,7 +7873,7 @@
                 </a:solidFill>
                 <a:latin typeface="Consolas"/>
               </a:rPr>
-              <a:t>247</a:t>
+              <a:t>253</a:t>
             </a:r>
           </a:p>
         </p:txBody>
@@ -8029,7 +8029,7 @@
                 </a:solidFill>
                 <a:latin typeface="Consolas"/>
               </a:rPr>
-              <a:t>60/247</a:t>
+              <a:t>60/253</a:t>
             </a:r>
           </a:p>
         </p:txBody>
@@ -8155,7 +8155,7 @@
                 </a:solidFill>
                 <a:latin typeface="Consolas"/>
               </a:rPr>
-              <a:t>222</a:t>
+              <a:t>238</a:t>
             </a:r>
           </a:p>
         </p:txBody>
@@ -8194,7 +8194,7 @@
                 </a:solidFill>
                 <a:latin typeface="Consolas"/>
               </a:rPr>
-              <a:t>0.699</a:t>
+              <a:t>0.718</a:t>
             </a:r>
           </a:p>
         </p:txBody>
@@ -8272,7 +8272,7 @@
                 </a:solidFill>
                 <a:latin typeface="Consolas"/>
               </a:rPr>
-              <a:t>0.855</a:t>
+              <a:t>0.867</a:t>
             </a:r>
           </a:p>
         </p:txBody>
@@ -8311,7 +8311,7 @@
                 </a:solidFill>
                 <a:latin typeface="Consolas"/>
               </a:rPr>
-              <a:t>45/222</a:t>
+              <a:t>45/238</a:t>
             </a:r>
           </a:p>
         </p:txBody>
@@ -8437,7 +8437,7 @@
                 </a:solidFill>
                 <a:latin typeface="Consolas"/>
               </a:rPr>
-              <a:t>155</a:t>
+              <a:t>156</a:t>
             </a:r>
           </a:p>
         </p:txBody>
@@ -8593,7 +8593,7 @@
                 </a:solidFill>
                 <a:latin typeface="Consolas"/>
               </a:rPr>
-              <a:t>19/155</a:t>
+              <a:t>19/156</a:t>
             </a:r>
           </a:p>
         </p:txBody>
@@ -8719,7 +8719,7 @@
                 </a:solidFill>
                 <a:latin typeface="Consolas"/>
               </a:rPr>
-              <a:t>247</a:t>
+              <a:t>253</a:t>
             </a:r>
           </a:p>
         </p:txBody>
@@ -8875,7 +8875,7 @@
                 </a:solidFill>
                 <a:latin typeface="Consolas"/>
               </a:rPr>
-              <a:t>102/247</a:t>
+              <a:t>102/253</a:t>
             </a:r>
           </a:p>
         </p:txBody>
@@ -9001,7 +9001,7 @@
                 </a:solidFill>
                 <a:latin typeface="Consolas"/>
               </a:rPr>
-              <a:t>246</a:t>
+              <a:t>253</a:t>
             </a:r>
           </a:p>
         </p:txBody>
@@ -9040,7 +9040,7 @@
                 </a:solidFill>
                 <a:latin typeface="Consolas"/>
               </a:rPr>
-              <a:t>0.386</a:t>
+              <a:t>0.380</a:t>
             </a:r>
           </a:p>
         </p:txBody>
@@ -9079,7 +9079,7 @@
                 </a:solidFill>
                 <a:latin typeface="Consolas"/>
               </a:rPr>
-              <a:t>0.427</a:t>
+              <a:t>0.420</a:t>
             </a:r>
           </a:p>
         </p:txBody>
@@ -9118,7 +9118,7 @@
                 </a:solidFill>
                 <a:latin typeface="Consolas"/>
               </a:rPr>
-              <a:t>0.673</a:t>
+              <a:t>0.667</a:t>
             </a:r>
           </a:p>
         </p:txBody>
@@ -9157,7 +9157,7 @@
                 </a:solidFill>
                 <a:latin typeface="Consolas"/>
               </a:rPr>
-              <a:t>159/246</a:t>
+              <a:t>160/253</a:t>
             </a:r>
           </a:p>
         </p:txBody>
@@ -9283,7 +9283,7 @@
                 </a:solidFill>
                 <a:latin typeface="Consolas"/>
               </a:rPr>
-              <a:t>229</a:t>
+              <a:t>253</a:t>
             </a:r>
           </a:p>
         </p:txBody>
@@ -9322,7 +9322,7 @@
                 </a:solidFill>
                 <a:latin typeface="Consolas"/>
               </a:rPr>
-              <a:t>0.259</a:t>
+              <a:t>0.271</a:t>
             </a:r>
           </a:p>
         </p:txBody>
@@ -9361,7 +9361,7 @@
                 </a:solidFill>
                 <a:latin typeface="Consolas"/>
               </a:rPr>
-              <a:t>0.260</a:t>
+              <a:t>0.272</a:t>
             </a:r>
           </a:p>
         </p:txBody>
@@ -9400,7 +9400,7 @@
                 </a:solidFill>
                 <a:latin typeface="Consolas"/>
               </a:rPr>
-              <a:t>0.272</a:t>
+              <a:t>0.287</a:t>
             </a:r>
           </a:p>
         </p:txBody>
@@ -9439,7 +9439,7 @@
                 </a:solidFill>
                 <a:latin typeface="Consolas"/>
               </a:rPr>
-              <a:t>11/229</a:t>
+              <a:t>14/253</a:t>
             </a:r>
           </a:p>
         </p:txBody>
@@ -9565,7 +9565,7 @@
                 </a:solidFill>
                 <a:latin typeface="Consolas"/>
               </a:rPr>
-              <a:t>242</a:t>
+              <a:t>253</a:t>
             </a:r>
           </a:p>
         </p:txBody>
@@ -9604,7 +9604,7 @@
                 </a:solidFill>
                 <a:latin typeface="Consolas"/>
               </a:rPr>
-              <a:t>0.211</a:t>
+              <a:t>0.221</a:t>
             </a:r>
           </a:p>
         </p:txBody>
@@ -9643,7 +9643,7 @@
                 </a:solidFill>
                 <a:latin typeface="Consolas"/>
               </a:rPr>
-              <a:t>0.231</a:t>
+              <a:t>0.240</a:t>
             </a:r>
           </a:p>
         </p:txBody>
@@ -9682,7 +9682,7 @@
                 </a:solidFill>
                 <a:latin typeface="Consolas"/>
               </a:rPr>
-              <a:t>0.306</a:t>
+              <a:t>0.315</a:t>
             </a:r>
           </a:p>
         </p:txBody>
@@ -9721,7 +9721,7 @@
                 </a:solidFill>
                 <a:latin typeface="Consolas"/>
               </a:rPr>
-              <a:t>97/242</a:t>
+              <a:t>100/253</a:t>
             </a:r>
           </a:p>
         </p:txBody>

</xml_diff>